<commit_message>
feat: 12-month timeline, red/yellow rebrand, nav dropdowns, animations, bug fixes
- Timeline extended to 12 months (build 1-3, pilot 4-5, usage 6-9, scaling 10-12)
- Budget adjusted to $21K for 12-month hosting/API runway
- Colors changed to Busy Bees Singapore corporate red (#e8063c) and yellow (#fecd1b)
- Typography: Playfair Display serif headers, Inter body with cv11 neckless 'a'
- Nav simplified from 11 flat links to 3 categories (Home, Proposal, Demos) with dropdowns
- Added claymorphism-inspired multi-layer shadows, hover lift effects, button press animations
- Added animated floating background blobs with parallax on scroll
- Replaced ASCII architecture diagram with SVG
- Fixed dashboard chart animation bug (data-height read order)
- Fixed coach mode switching to update chat header title
- All sub-pages updated with new nav, fonts, blobs, and color references
- Slides regenerated with red primary, 12-month timeline, $21K budget
</commit_message>
<xml_diff>
--- a/slides/PedaForge_Proposal.pptx
+++ b/slides/PedaForge_Proposal.pptx
@@ -3165,7 +3165,7 @@
             <a:avLst/>
           </a:prstGeom>
           <a:solidFill>
-            <a:srgbClr val="01ABAA"/>
+            <a:srgbClr val="E8063C"/>
           </a:solidFill>
           <a:ln>
             <a:noFill/>
@@ -3372,7 +3372,7 @@
               </a:defRPr>
             </a:pPr>
             <a:r>
-              <a:t>Duration: 6 Months  |  Budget: SGD $20,000</a:t>
+              <a:t>Duration: 12 Months  |  Budget: SGD $21,000</a:t>
             </a:r>
           </a:p>
         </p:txBody>
@@ -3454,7 +3454,7 @@
             <a:avLst/>
           </a:prstGeom>
           <a:solidFill>
-            <a:srgbClr val="01ABAA"/>
+            <a:srgbClr val="E8063C"/>
           </a:solidFill>
           <a:ln>
             <a:noFill/>
@@ -3507,7 +3507,7 @@
             <a:pPr algn="l">
               <a:defRPr sz="1000" b="1">
                 <a:solidFill>
-                  <a:srgbClr val="01ABAA"/>
+                  <a:srgbClr val="E8063C"/>
                 </a:solidFill>
                 <a:latin typeface="Arial"/>
               </a:defRPr>
@@ -3612,7 +3612,7 @@
             <a:avLst/>
           </a:prstGeom>
           <a:solidFill>
-            <a:srgbClr val="01ABAA"/>
+            <a:srgbClr val="E8063C"/>
           </a:solidFill>
           <a:ln>
             <a:noFill/>
@@ -3701,7 +3701,7 @@
             <a:pPr algn="ctr">
               <a:defRPr sz="900" b="0">
                 <a:solidFill>
-                  <a:srgbClr val="01ABAA"/>
+                  <a:srgbClr val="E8063C"/>
                 </a:solidFill>
                 <a:latin typeface="Arial"/>
               </a:defRPr>
@@ -4189,7 +4189,7 @@
             <a:avLst/>
           </a:prstGeom>
           <a:solidFill>
-            <a:srgbClr val="01ABAA"/>
+            <a:srgbClr val="E8063C"/>
           </a:solidFill>
           <a:ln>
             <a:noFill/>
@@ -4242,7 +4242,7 @@
             <a:pPr algn="l">
               <a:defRPr sz="1000" b="1">
                 <a:solidFill>
-                  <a:srgbClr val="01ABAA"/>
+                  <a:srgbClr val="E8063C"/>
                 </a:solidFill>
                 <a:latin typeface="Arial"/>
               </a:defRPr>
@@ -4393,7 +4393,7 @@
             <a:pPr algn="l">
               <a:defRPr sz="900" b="1">
                 <a:solidFill>
-                  <a:srgbClr val="01ABAA"/>
+                  <a:srgbClr val="E8063C"/>
                 </a:solidFill>
                 <a:latin typeface="Arial"/>
               </a:defRPr>
@@ -5279,7 +5279,7 @@
             <a:avLst/>
           </a:prstGeom>
           <a:solidFill>
-            <a:srgbClr val="01ABAA"/>
+            <a:srgbClr val="E8063C"/>
           </a:solidFill>
           <a:ln>
             <a:noFill/>
@@ -5538,7 +5538,7 @@
             <a:avLst/>
           </a:prstGeom>
           <a:solidFill>
-            <a:srgbClr val="01ABAA"/>
+            <a:srgbClr val="E8063C"/>
           </a:solidFill>
           <a:ln>
             <a:noFill/>
@@ -5597,7 +5597,7 @@
               </a:defRPr>
             </a:pPr>
             <a:r>
-              <a:t>SGD $20,000  |  6 Months  |  IDP 2.0 Aligned</a:t>
+              <a:t>SGD $21,000  |  12 Months  |  IDP 2.0 Aligned</a:t>
             </a:r>
           </a:p>
         </p:txBody>
@@ -5643,7 +5643,7 @@
             <a:avLst/>
           </a:prstGeom>
           <a:solidFill>
-            <a:srgbClr val="01ABAA"/>
+            <a:srgbClr val="E8063C"/>
           </a:solidFill>
           <a:ln>
             <a:noFill/>
@@ -5696,7 +5696,7 @@
             <a:pPr algn="l">
               <a:defRPr sz="1000" b="1">
                 <a:solidFill>
-                  <a:srgbClr val="01ABAA"/>
+                  <a:srgbClr val="E8063C"/>
                 </a:solidFill>
                 <a:latin typeface="Arial"/>
               </a:defRPr>
@@ -6417,7 +6417,7 @@
             <a:avLst/>
           </a:prstGeom>
           <a:solidFill>
-            <a:srgbClr val="01ABAA"/>
+            <a:srgbClr val="E8063C"/>
           </a:solidFill>
           <a:ln>
             <a:noFill/>
@@ -6470,7 +6470,7 @@
             <a:pPr algn="l">
               <a:defRPr sz="1000" b="1">
                 <a:solidFill>
-                  <a:srgbClr val="01ABAA"/>
+                  <a:srgbClr val="E8063C"/>
                 </a:solidFill>
                 <a:latin typeface="Arial"/>
               </a:defRPr>
@@ -6657,7 +6657,7 @@
             <a:pPr algn="l">
               <a:defRPr sz="800" b="1">
                 <a:solidFill>
-                  <a:srgbClr val="01ABAA"/>
+                  <a:srgbClr val="E8063C"/>
                 </a:solidFill>
                 <a:latin typeface="Arial"/>
               </a:defRPr>
@@ -8779,7 +8779,7 @@
             <a:avLst/>
           </a:prstGeom>
           <a:solidFill>
-            <a:srgbClr val="01ABAA"/>
+            <a:srgbClr val="E8063C"/>
           </a:solidFill>
           <a:ln>
             <a:noFill/>
@@ -8832,7 +8832,7 @@
             <a:pPr algn="l">
               <a:defRPr sz="1000" b="1">
                 <a:solidFill>
-                  <a:srgbClr val="01ABAA"/>
+                  <a:srgbClr val="E8063C"/>
                 </a:solidFill>
                 <a:latin typeface="Arial"/>
               </a:defRPr>
@@ -8894,7 +8894,7 @@
             <a:avLst/>
           </a:prstGeom>
           <a:solidFill>
-            <a:srgbClr val="01ABAA"/>
+            <a:srgbClr val="E8063C"/>
           </a:solidFill>
           <a:ln>
             <a:noFill/>
@@ -10117,7 +10117,7 @@
             <a:pPr algn="ctr">
               <a:defRPr sz="1300" b="1">
                 <a:solidFill>
-                  <a:srgbClr val="01ABAA"/>
+                  <a:srgbClr val="E8063C"/>
                 </a:solidFill>
                 <a:latin typeface="Arial"/>
               </a:defRPr>
@@ -10169,7 +10169,7 @@
             <a:avLst/>
           </a:prstGeom>
           <a:solidFill>
-            <a:srgbClr val="01ABAA"/>
+            <a:srgbClr val="E8063C"/>
           </a:solidFill>
           <a:ln>
             <a:noFill/>
@@ -10222,7 +10222,7 @@
             <a:pPr algn="l">
               <a:defRPr sz="1000" b="1">
                 <a:solidFill>
-                  <a:srgbClr val="01ABAA"/>
+                  <a:srgbClr val="E8063C"/>
                 </a:solidFill>
                 <a:latin typeface="Arial"/>
               </a:defRPr>
@@ -11020,7 +11020,7 @@
             <a:pPr algn="l">
               <a:defRPr sz="1000" b="1">
                 <a:solidFill>
-                  <a:srgbClr val="01ABAA"/>
+                  <a:srgbClr val="E8063C"/>
                 </a:solidFill>
                 <a:latin typeface="Arial"/>
               </a:defRPr>
@@ -11092,7 +11092,7 @@
             <a:pPr algn="l">
               <a:defRPr sz="1000" b="1">
                 <a:solidFill>
-                  <a:srgbClr val="01ABAA"/>
+                  <a:srgbClr val="E8063C"/>
                 </a:solidFill>
                 <a:latin typeface="Arial"/>
               </a:defRPr>
@@ -11164,7 +11164,7 @@
             <a:pPr algn="l">
               <a:defRPr sz="1000" b="1">
                 <a:solidFill>
-                  <a:srgbClr val="01ABAA"/>
+                  <a:srgbClr val="E8063C"/>
                 </a:solidFill>
                 <a:latin typeface="Arial"/>
               </a:defRPr>
@@ -11236,7 +11236,7 @@
             <a:pPr algn="l">
               <a:defRPr sz="1000" b="1">
                 <a:solidFill>
-                  <a:srgbClr val="01ABAA"/>
+                  <a:srgbClr val="E8063C"/>
                 </a:solidFill>
                 <a:latin typeface="Arial"/>
               </a:defRPr>
@@ -11308,7 +11308,7 @@
             <a:pPr algn="l">
               <a:defRPr sz="1000" b="1">
                 <a:solidFill>
-                  <a:srgbClr val="01ABAA"/>
+                  <a:srgbClr val="E8063C"/>
                 </a:solidFill>
                 <a:latin typeface="Arial"/>
               </a:defRPr>
@@ -11396,7 +11396,7 @@
             <a:avLst/>
           </a:prstGeom>
           <a:solidFill>
-            <a:srgbClr val="01ABAA"/>
+            <a:srgbClr val="E8063C"/>
           </a:solidFill>
           <a:ln>
             <a:noFill/>
@@ -11449,7 +11449,7 @@
             <a:pPr algn="l">
               <a:defRPr sz="1000" b="1">
                 <a:solidFill>
-                  <a:srgbClr val="01ABAA"/>
+                  <a:srgbClr val="E8063C"/>
                 </a:solidFill>
                 <a:latin typeface="Arial"/>
               </a:defRPr>
@@ -11564,7 +11564,7 @@
             <a:pPr algn="ctr">
               <a:defRPr sz="3600" b="1">
                 <a:solidFill>
-                  <a:srgbClr val="01ABAA"/>
+                  <a:srgbClr val="E8063C"/>
                 </a:solidFill>
                 <a:latin typeface="Arial"/>
               </a:defRPr>
@@ -12467,7 +12467,7 @@
             <a:avLst/>
           </a:prstGeom>
           <a:solidFill>
-            <a:srgbClr val="01ABAA"/>
+            <a:srgbClr val="E8063C"/>
           </a:solidFill>
           <a:ln>
             <a:noFill/>
@@ -12520,13 +12520,13 @@
             <a:pPr algn="l">
               <a:defRPr sz="1000" b="1">
                 <a:solidFill>
-                  <a:srgbClr val="01ABAA"/>
-                </a:solidFill>
-                <a:latin typeface="Arial"/>
-              </a:defRPr>
-            </a:pPr>
-            <a:r>
-              <a:t>6-MONTH ROADMAP</a:t>
+                  <a:srgbClr val="E8063C"/>
+                </a:solidFill>
+                <a:latin typeface="Arial"/>
+              </a:defRPr>
+            </a:pPr>
+            <a:r>
+              <a:t>12-MONTH ROADMAP</a:t>
             </a:r>
           </a:p>
         </p:txBody>
@@ -12625,7 +12625,7 @@
             <a:avLst/>
           </a:prstGeom>
           <a:solidFill>
-            <a:srgbClr val="01ABAA"/>
+            <a:srgbClr val="E8063C"/>
           </a:solidFill>
           <a:ln>
             <a:noFill/>
@@ -12678,13 +12678,13 @@
             <a:pPr algn="ctr">
               <a:defRPr sz="800" b="1">
                 <a:solidFill>
-                  <a:srgbClr val="01ABAA"/>
-                </a:solidFill>
-                <a:latin typeface="Arial"/>
-              </a:defRPr>
-            </a:pPr>
-            <a:r>
-              <a:t>Months 1–2</a:t>
+                  <a:srgbClr val="E8063C"/>
+                </a:solidFill>
+                <a:latin typeface="Arial"/>
+              </a:defRPr>
+            </a:pPr>
+            <a:r>
+              <a:t>Months 1–3</a:t>
             </a:r>
           </a:p>
         </p:txBody>
@@ -12760,11 +12760,11 @@
               </a:defRPr>
             </a:pPr>
             <a:r>
-              <a:t>Infrastructure, AI prompts,</a:t>
+              <a:t>Azure infrastructure,</a:t>
             </a:r>
             <a:br/>
             <a:r>
-              <a:t>platform build, PDPA</a:t>
+              <a:t>core modules, AI prompts</a:t>
             </a:r>
           </a:p>
         </p:txBody>
@@ -12843,7 +12843,7 @@
               </a:defRPr>
             </a:pPr>
             <a:r>
-              <a:t>Month 3</a:t>
+              <a:t>Months 4–5</a:t>
             </a:r>
           </a:p>
         </p:txBody>
@@ -12879,11 +12879,11 @@
               </a:defRPr>
             </a:pPr>
             <a:r>
-              <a:t>Pilot</a:t>
+              <a:t>Pilot Deployment</a:t>
             </a:r>
             <a:br/>
             <a:r>
-              <a:t>Deployment</a:t>
+              <a:t>&amp; Onboarding</a:t>
             </a:r>
           </a:p>
         </p:txBody>
@@ -13002,7 +13002,7 @@
               </a:defRPr>
             </a:pPr>
             <a:r>
-              <a:t>Months 4–5</a:t>
+              <a:t>Months 6–9</a:t>
             </a:r>
           </a:p>
         </p:txBody>
@@ -13038,11 +13038,11 @@
               </a:defRPr>
             </a:pPr>
             <a:r>
-              <a:t>Active</a:t>
+              <a:t>Active Usage</a:t>
             </a:r>
             <a:br/>
             <a:r>
-              <a:t>Execution</a:t>
+              <a:t>&amp; Iteration</a:t>
             </a:r>
           </a:p>
         </p:txBody>
@@ -13082,7 +13082,7 @@
             </a:r>
             <a:br/>
             <a:r>
-              <a:t>first IDPs generated</a:t>
+              <a:t>IDPs, AI coaching</a:t>
             </a:r>
           </a:p>
         </p:txBody>
@@ -13161,7 +13161,7 @@
               </a:defRPr>
             </a:pPr>
             <a:r>
-              <a:t>Month 6</a:t>
+              <a:t>Months 10–12</a:t>
             </a:r>
           </a:p>
         </p:txBody>
@@ -13197,11 +13197,11 @@
               </a:defRPr>
             </a:pPr>
             <a:r>
-              <a:t>Impact Assessment</a:t>
+              <a:t>Assessment</a:t>
             </a:r>
             <a:br/>
             <a:r>
-              <a:t>&amp; Reporting</a:t>
+              <a:t>&amp; Scaling</a:t>
             </a:r>
           </a:p>
         </p:txBody>
@@ -13237,11 +13237,11 @@
               </a:defRPr>
             </a:pPr>
             <a:r>
-              <a:t>Findings, commercialisation</a:t>
+              <a:t>Impact report, ECDA</a:t>
             </a:r>
             <a:br/>
             <a:r>
-              <a:t>roadmap, ECDA presentation</a:t>
+              <a:t>presentation, scale plan</a:t>
             </a:r>
           </a:p>
         </p:txBody>
@@ -13313,7 +13313,7 @@
               </a:defRPr>
             </a:pPr>
             <a:r>
-              <a:t>✓  Month 2: AI prompts validated against QTT rubric</a:t>
+              <a:t>✓  Month 3: AI prompts validated against QTT rubric</a:t>
             </a:r>
           </a:p>
         </p:txBody>
@@ -13349,7 +13349,7 @@
               </a:defRPr>
             </a:pPr>
             <a:r>
-              <a:t>✓  Month 3: First educators onboarded with training</a:t>
+              <a:t>✓  Month 5: First educators onboarded with training</a:t>
             </a:r>
           </a:p>
         </p:txBody>
@@ -13385,7 +13385,7 @@
               </a:defRPr>
             </a:pPr>
             <a:r>
-              <a:t>✓  Month 5: First SFw-aligned IDPs auto-generated</a:t>
+              <a:t>✓  Month 9: First SFw-aligned IDPs auto-generated</a:t>
             </a:r>
           </a:p>
         </p:txBody>
@@ -13421,7 +13421,7 @@
               </a:defRPr>
             </a:pPr>
             <a:r>
-              <a:t>✓  Month 6: Final impact report to ECDA</a:t>
+              <a:t>✓  Month 12: Final impact report to ECDA</a:t>
             </a:r>
           </a:p>
         </p:txBody>
@@ -13467,7 +13467,7 @@
             <a:avLst/>
           </a:prstGeom>
           <a:solidFill>
-            <a:srgbClr val="01ABAA"/>
+            <a:srgbClr val="E8063C"/>
           </a:solidFill>
           <a:ln>
             <a:noFill/>
@@ -13520,7 +13520,7 @@
             <a:pPr algn="l">
               <a:defRPr sz="1000" b="1">
                 <a:solidFill>
-                  <a:srgbClr val="01ABAA"/>
+                  <a:srgbClr val="E8063C"/>
                 </a:solidFill>
                 <a:latin typeface="Arial"/>
               </a:defRPr>
@@ -13619,13 +13619,13 @@
         <p:spPr>
           <a:xfrm>
             <a:off x="548640" y="1188720"/>
-            <a:ext cx="2464308" cy="502920"/>
+            <a:ext cx="2564892" cy="502920"/>
           </a:xfrm>
           <a:prstGeom prst="rect">
             <a:avLst/>
           </a:prstGeom>
           <a:solidFill>
-            <a:srgbClr val="01ABAA"/>
+            <a:srgbClr val="E8063C"/>
           </a:solidFill>
           <a:ln>
             <a:noFill/>
@@ -13720,7 +13720,7 @@
               </a:defRPr>
             </a:pPr>
             <a:r>
-              <a:t>$9,800</a:t>
+              <a:t>$10,800</a:t>
             </a:r>
           </a:p>
         </p:txBody>
@@ -13756,7 +13756,7 @@
               </a:defRPr>
             </a:pPr>
             <a:r>
-              <a:t>49%</a:t>
+              <a:t>51%</a:t>
             </a:r>
           </a:p>
         </p:txBody>
@@ -13813,7 +13813,7 @@
         <p:spPr>
           <a:xfrm>
             <a:off x="548640" y="1874519"/>
-            <a:ext cx="804672" cy="502920"/>
+            <a:ext cx="754380" cy="502920"/>
           </a:xfrm>
           <a:prstGeom prst="rect">
             <a:avLst/>
@@ -13950,7 +13950,7 @@
               </a:defRPr>
             </a:pPr>
             <a:r>
-              <a:t>16%</a:t>
+              <a:t>15%</a:t>
             </a:r>
           </a:p>
         </p:txBody>
@@ -14007,7 +14007,7 @@
         <p:spPr>
           <a:xfrm>
             <a:off x="548640" y="2560320"/>
-            <a:ext cx="1106424" cy="502920"/>
+            <a:ext cx="1056132" cy="502920"/>
           </a:xfrm>
           <a:prstGeom prst="rect">
             <a:avLst/>
@@ -14144,7 +14144,7 @@
               </a:defRPr>
             </a:pPr>
             <a:r>
-              <a:t>22%</a:t>
+              <a:t>21%</a:t>
             </a:r>
           </a:p>
         </p:txBody>
@@ -14453,7 +14453,7 @@
               </a:defRPr>
             </a:pPr>
             <a:r>
-              <a:t>SGD $20,000</a:t>
+              <a:t>SGD $21,000</a:t>
             </a:r>
           </a:p>
         </p:txBody>
@@ -14525,7 +14525,7 @@
               </a:defRPr>
             </a:pPr>
             <a:r>
-              <a:t>Azure Hosting: $200/month x 6 months</a:t>
+              <a:t>Azure Hosting: $150/month x 12 months</a:t>
             </a:r>
           </a:p>
         </p:txBody>
@@ -14561,7 +14561,7 @@
               </a:defRPr>
             </a:pPr>
             <a:r>
-              <a:t>Claude Haiku via Azure AI Foundry: $100/month x 6 months</a:t>
+              <a:t>Claude Haiku via Azure AI Foundry: $85/month x 12 months</a:t>
             </a:r>
           </a:p>
         </p:txBody>

</xml_diff>

<commit_message>
feat: Inter-only cv11 fonts, GPT-4o-mini, Angular, research citations, UI fixes
- Remove Playfair Display; use Inter 400-900 with cv11 for all text
- Switch AI model from Claude Haiku 4.5 to GPT-4o-mini via Azure OpenAI
- Switch frontend framework from React/Next.js to Angular
- Add research citations: Harper et al. 2025, OECD TALIS 2018, EPPE 2004, ACE 2017
- Add coaching progression bar (Supportive Growth -> Critical Analysis)
- Fix hero badge text, mockup padding, nav dropdown pill styling
- Update copyright to PedaForge; Anita Teo across all pages
- Fix stale 6-month refs in application guide
- Regenerate PPTX slides
</commit_message>
<xml_diff>
--- a/slides/PedaForge_Proposal.pptx
+++ b/slides/PedaForge_Proposal.pptx
@@ -3945,7 +3945,7 @@
             </a:r>
             <a:br/>
             <a:r>
-              <a:t>via Azure AI Foundry, deployment</a:t>
+              <a:t>via Azure OpenAI, deployment</a:t>
             </a:r>
           </a:p>
         </p:txBody>
@@ -10379,7 +10379,7 @@
               </a:defRPr>
             </a:pPr>
             <a:r>
-              <a:t>React / Next.js, TypeScript, TailwindCSS</a:t>
+              <a:t>Angular, TypeScript, TailwindCSS</a:t>
             </a:r>
           </a:p>
         </p:txBody>
@@ -10609,7 +10609,7 @@
               </a:defRPr>
             </a:pPr>
             <a:r>
-              <a:t>Claude Haiku 4.5 via Azure AI Foundry</a:t>
+              <a:t>GPT-4o-mini via Azure OpenAI</a:t>
             </a:r>
           </a:p>
         </p:txBody>
@@ -14561,7 +14561,7 @@
               </a:defRPr>
             </a:pPr>
             <a:r>
-              <a:t>Claude Haiku via Azure AI Foundry: $85/month x 12 months</a:t>
+              <a:t>GPT-4o-mini via Azure OpenAI: $85/month x 12 months</a:t>
             </a:r>
           </a:p>
         </p:txBody>

</xml_diff>

<commit_message>
feat: Nunito Sans font, GPT-4.1-mini, Playfair Display restored, premium animations
- Restore Playfair Display for all headings (was incorrectly removed)
- Swap body font from Inter to Nunito Sans (single-story 'a' by default)
- Upgrade AI model from GPT-4o-mini to GPT-4.1-mini (better reasoning,
  anti-sycophancy, 1M context, ~$12.50/month on Azure OpenAI)
- Fix nav dropdown link padding: 8px container padding, rounded hover pills
- Add 8 premium animation enhancements:
  - Scroll progress indicator bar (red-to-yellow gradient)
  - Directional scroll reveals (left/right slide, scale-up)
  - Text clip-path wipe on section headings
  - Staggered animation delays on grid children
  - Magnetic 3D tilt hover on feature/KPI/team cards
  - Button ripple effect on click
  - Hero section parallax depth layers
  - Typing indicator dots in coaching chat demo
- Improve counter animation easing (easeOutExpo)
- Regenerate PPTX slides
</commit_message>
<xml_diff>
--- a/slides/PedaForge_Proposal.pptx
+++ b/slides/PedaForge_Proposal.pptx
@@ -10609,7 +10609,7 @@
               </a:defRPr>
             </a:pPr>
             <a:r>
-              <a:t>GPT-4o-mini via Azure OpenAI</a:t>
+              <a:t>GPT-4.1-mini via Azure OpenAI</a:t>
             </a:r>
           </a:p>
         </p:txBody>
@@ -14561,7 +14561,7 @@
               </a:defRPr>
             </a:pPr>
             <a:r>
-              <a:t>GPT-4o-mini via Azure OpenAI: $85/month x 12 months</a:t>
+              <a:t>GPT-4.1-mini via Azure OpenAI: $85/month x 12 months</a:t>
             </a:r>
           </a:p>
         </p:txBody>

</xml_diff>